<commit_message>
Add clone count, expanded clones, and R/S ratio slides to presentation
Three new results slides (8-10) showing clone count by disease,
expanded clones count and size, and replacement/silent mutation
ratio with CDR vs FW region comparison.

Co-Authored-By: Claude Opus 4.6 <noreply@anthropic.com>
Claude-Session: https://claude.ai/code/session_01D55fsgxxDUfDTuPfRhF34U
</commit_message>
<xml_diff>
--- a/IS-API_Presentation.pptx
+++ b/IS-API_Presentation.pptx
@@ -15,9 +15,12 @@
     <p:sldId id="263" r:id="rId9"/>
     <p:sldId id="264" r:id="rId10"/>
     <p:sldId id="265" r:id="rId11"/>
+    <p:sldId id="266" r:id="rId12"/>
+    <p:sldId id="267" r:id="rId13"/>
+    <p:sldId id="268" r:id="rId14"/>
   </p:sldIdLst>
   <p:notesMasterIdLst>
-    <p:notesMasterId r:id="rId12"/>
+    <p:notesMasterId r:id="rId15"/>
   </p:notesMasterIdLst>
   <p:sldSz cx="12192000" cy="6858000"/>
   <p:notesSz cx="6858000" cy="12192000"/>
@@ -623,6 +626,270 @@
             <a:fld id="{F7021451-1387-4CA6-816F-3879F97B5CBC}" type="slidenum">
               <a:rPr lang="en-US"/>
               <a:t>10</a:t>
+            </a:fld>
+            <a:endParaRPr lang="en-US"/>
+          </a:p>
+        </p:txBody>
+      </p:sp>
+    </p:spTree>
+    <p:extLst>
+      <p:ext uri="{BB962C8B-B14F-4D97-AF65-F5344CB8AC3E}">
+        <p14:creationId xmlns:p14="http://schemas.microsoft.com/office/powerpoint/2010/main" val="1024086991"/>
+      </p:ext>
+    </p:extLst>
+  </p:cSld>
+  <p:clrMapOvr>
+    <a:masterClrMapping/>
+  </p:clrMapOvr>
+</p:notes>
+</file>
+
+<file path=ppt/notesSlides/notesSlide11.xml><?xml version="1.0" encoding="utf-8"?>
+<p:notes xmlns:a="http://schemas.openxmlformats.org/drawingml/2006/main" xmlns:r="http://schemas.openxmlformats.org/officeDocument/2006/relationships" xmlns:p="http://schemas.openxmlformats.org/presentationml/2006/main">
+  <p:cSld>
+    <p:spTree>
+      <p:nvGrpSpPr>
+        <p:cNvPr id="1" name=""/>
+        <p:cNvGrpSpPr/>
+        <p:nvPr/>
+      </p:nvGrpSpPr>
+      <p:grpSpPr>
+        <a:xfrm>
+          <a:off x="0" y="0"/>
+          <a:ext cx="0" cy="0"/>
+          <a:chOff x="0" y="0"/>
+          <a:chExt cx="0" cy="0"/>
+        </a:xfrm>
+      </p:grpSpPr>
+      <p:sp>
+        <p:nvSpPr>
+          <p:cNvPr id="2" name="Slide Image Placeholder 1"/>
+          <p:cNvSpPr>
+            <a:spLocks noGrp="1" noRot="1" noChangeAspect="1"/>
+          </p:cNvSpPr>
+          <p:nvPr>
+            <p:ph type="sldImg"/>
+          </p:nvPr>
+        </p:nvSpPr>
+        <p:spPr/>
+      </p:sp>
+      <p:sp>
+        <p:nvSpPr>
+          <p:cNvPr id="3" name="Notes Placeholder 2"/>
+          <p:cNvSpPr>
+            <a:spLocks noGrp="1"/>
+          </p:cNvSpPr>
+          <p:nvPr>
+            <p:ph type="body" idx="1"/>
+          </p:nvPr>
+        </p:nvSpPr>
+        <p:spPr/>
+        <p:txBody>
+          <a:bodyPr/>
+          <a:lstStyle/>
+          <a:p>
+            <a:r>
+              <a:rPr lang="en-US" dirty="0"/>
+              <a:t/>
+            </a:r>
+            <a:endParaRPr lang="en-US" dirty="0"/>
+          </a:p>
+        </p:txBody>
+      </p:sp>
+      <p:sp>
+        <p:nvSpPr>
+          <p:cNvPr id="4" name="Slide Number Placeholder 3"/>
+          <p:cNvSpPr>
+            <a:spLocks noGrp="1"/>
+          </p:cNvSpPr>
+          <p:nvPr>
+            <p:ph type="sldNum" sz="quarter" idx="10"/>
+          </p:nvPr>
+        </p:nvSpPr>
+        <p:spPr/>
+        <p:txBody>
+          <a:bodyPr/>
+          <a:lstStyle/>
+          <a:p>
+            <a:fld id="{F7021451-1387-4CA6-816F-3879F97B5CBC}" type="slidenum">
+              <a:rPr lang="en-US"/>
+              <a:t>11</a:t>
+            </a:fld>
+            <a:endParaRPr lang="en-US"/>
+          </a:p>
+        </p:txBody>
+      </p:sp>
+    </p:spTree>
+    <p:extLst>
+      <p:ext uri="{BB962C8B-B14F-4D97-AF65-F5344CB8AC3E}">
+        <p14:creationId xmlns:p14="http://schemas.microsoft.com/office/powerpoint/2010/main" val="1024086991"/>
+      </p:ext>
+    </p:extLst>
+  </p:cSld>
+  <p:clrMapOvr>
+    <a:masterClrMapping/>
+  </p:clrMapOvr>
+</p:notes>
+</file>
+
+<file path=ppt/notesSlides/notesSlide12.xml><?xml version="1.0" encoding="utf-8"?>
+<p:notes xmlns:a="http://schemas.openxmlformats.org/drawingml/2006/main" xmlns:r="http://schemas.openxmlformats.org/officeDocument/2006/relationships" xmlns:p="http://schemas.openxmlformats.org/presentationml/2006/main">
+  <p:cSld>
+    <p:spTree>
+      <p:nvGrpSpPr>
+        <p:cNvPr id="1" name=""/>
+        <p:cNvGrpSpPr/>
+        <p:nvPr/>
+      </p:nvGrpSpPr>
+      <p:grpSpPr>
+        <a:xfrm>
+          <a:off x="0" y="0"/>
+          <a:ext cx="0" cy="0"/>
+          <a:chOff x="0" y="0"/>
+          <a:chExt cx="0" cy="0"/>
+        </a:xfrm>
+      </p:grpSpPr>
+      <p:sp>
+        <p:nvSpPr>
+          <p:cNvPr id="2" name="Slide Image Placeholder 1"/>
+          <p:cNvSpPr>
+            <a:spLocks noGrp="1" noRot="1" noChangeAspect="1"/>
+          </p:cNvSpPr>
+          <p:nvPr>
+            <p:ph type="sldImg"/>
+          </p:nvPr>
+        </p:nvSpPr>
+        <p:spPr/>
+      </p:sp>
+      <p:sp>
+        <p:nvSpPr>
+          <p:cNvPr id="3" name="Notes Placeholder 2"/>
+          <p:cNvSpPr>
+            <a:spLocks noGrp="1"/>
+          </p:cNvSpPr>
+          <p:nvPr>
+            <p:ph type="body" idx="1"/>
+          </p:nvPr>
+        </p:nvSpPr>
+        <p:spPr/>
+        <p:txBody>
+          <a:bodyPr/>
+          <a:lstStyle/>
+          <a:p>
+            <a:r>
+              <a:rPr lang="en-US" dirty="0"/>
+              <a:t/>
+            </a:r>
+            <a:endParaRPr lang="en-US" dirty="0"/>
+          </a:p>
+        </p:txBody>
+      </p:sp>
+      <p:sp>
+        <p:nvSpPr>
+          <p:cNvPr id="4" name="Slide Number Placeholder 3"/>
+          <p:cNvSpPr>
+            <a:spLocks noGrp="1"/>
+          </p:cNvSpPr>
+          <p:nvPr>
+            <p:ph type="sldNum" sz="quarter" idx="10"/>
+          </p:nvPr>
+        </p:nvSpPr>
+        <p:spPr/>
+        <p:txBody>
+          <a:bodyPr/>
+          <a:lstStyle/>
+          <a:p>
+            <a:fld id="{F7021451-1387-4CA6-816F-3879F97B5CBC}" type="slidenum">
+              <a:rPr lang="en-US"/>
+              <a:t>12</a:t>
+            </a:fld>
+            <a:endParaRPr lang="en-US"/>
+          </a:p>
+        </p:txBody>
+      </p:sp>
+    </p:spTree>
+    <p:extLst>
+      <p:ext uri="{BB962C8B-B14F-4D97-AF65-F5344CB8AC3E}">
+        <p14:creationId xmlns:p14="http://schemas.microsoft.com/office/powerpoint/2010/main" val="1024086991"/>
+      </p:ext>
+    </p:extLst>
+  </p:cSld>
+  <p:clrMapOvr>
+    <a:masterClrMapping/>
+  </p:clrMapOvr>
+</p:notes>
+</file>
+
+<file path=ppt/notesSlides/notesSlide13.xml><?xml version="1.0" encoding="utf-8"?>
+<p:notes xmlns:a="http://schemas.openxmlformats.org/drawingml/2006/main" xmlns:r="http://schemas.openxmlformats.org/officeDocument/2006/relationships" xmlns:p="http://schemas.openxmlformats.org/presentationml/2006/main">
+  <p:cSld>
+    <p:spTree>
+      <p:nvGrpSpPr>
+        <p:cNvPr id="1" name=""/>
+        <p:cNvGrpSpPr/>
+        <p:nvPr/>
+      </p:nvGrpSpPr>
+      <p:grpSpPr>
+        <a:xfrm>
+          <a:off x="0" y="0"/>
+          <a:ext cx="0" cy="0"/>
+          <a:chOff x="0" y="0"/>
+          <a:chExt cx="0" cy="0"/>
+        </a:xfrm>
+      </p:grpSpPr>
+      <p:sp>
+        <p:nvSpPr>
+          <p:cNvPr id="2" name="Slide Image Placeholder 1"/>
+          <p:cNvSpPr>
+            <a:spLocks noGrp="1" noRot="1" noChangeAspect="1"/>
+          </p:cNvSpPr>
+          <p:nvPr>
+            <p:ph type="sldImg"/>
+          </p:nvPr>
+        </p:nvSpPr>
+        <p:spPr/>
+      </p:sp>
+      <p:sp>
+        <p:nvSpPr>
+          <p:cNvPr id="3" name="Notes Placeholder 2"/>
+          <p:cNvSpPr>
+            <a:spLocks noGrp="1"/>
+          </p:cNvSpPr>
+          <p:nvPr>
+            <p:ph type="body" idx="1"/>
+          </p:nvPr>
+        </p:nvSpPr>
+        <p:spPr/>
+        <p:txBody>
+          <a:bodyPr/>
+          <a:lstStyle/>
+          <a:p>
+            <a:r>
+              <a:rPr lang="en-US" dirty="0"/>
+              <a:t/>
+            </a:r>
+            <a:endParaRPr lang="en-US" dirty="0"/>
+          </a:p>
+        </p:txBody>
+      </p:sp>
+      <p:sp>
+        <p:nvSpPr>
+          <p:cNvPr id="4" name="Slide Number Placeholder 3"/>
+          <p:cNvSpPr>
+            <a:spLocks noGrp="1"/>
+          </p:cNvSpPr>
+          <p:nvPr>
+            <p:ph type="sldNum" sz="quarter" idx="10"/>
+          </p:nvPr>
+        </p:nvSpPr>
+        <p:spPr/>
+        <p:txBody>
+          <a:bodyPr/>
+          <a:lstStyle/>
+          <a:p>
+            <a:fld id="{F7021451-1387-4CA6-816F-3879F97B5CBC}" type="slidenum">
+              <a:rPr lang="en-US"/>
+              <a:t>13</a:t>
             </a:fld>
             <a:endParaRPr lang="en-US"/>
           </a:p>
@@ -1869,6 +2136,889 @@
     <p:bg>
       <p:bgPr>
         <a:solidFill>
+          <a:srgbClr val="FFFFFF"/>
+        </a:solidFill>
+      </p:bgPr>
+    </p:bg>
+    <p:spTree>
+      <p:nvGrpSpPr>
+        <p:cNvPr id="1" name=""/>
+        <p:cNvGrpSpPr/>
+        <p:nvPr/>
+      </p:nvGrpSpPr>
+      <p:grpSpPr>
+        <a:xfrm>
+          <a:off x="0" y="0"/>
+          <a:ext cx="0" cy="0"/>
+          <a:chOff x="0" y="0"/>
+          <a:chExt cx="0" cy="0"/>
+        </a:xfrm>
+      </p:grpSpPr>
+      <p:sp>
+        <p:nvSpPr>
+          <p:cNvPr id="2" name="Text 0"/>
+          <p:cNvSpPr/>
+          <p:nvPr/>
+        </p:nvSpPr>
+        <p:spPr>
+          <a:xfrm>
+            <a:off x="731520" y="274320"/>
+            <a:ext cx="10515600" cy="731520"/>
+          </a:xfrm>
+          <a:prstGeom prst="rect">
+            <a:avLst/>
+          </a:prstGeom>
+          <a:noFill/>
+          <a:ln/>
+        </p:spPr>
+        <p:txBody>
+          <a:bodyPr wrap="square" rtlCol="0" anchor="ctr"/>
+          <a:lstStyle/>
+          <a:p>
+            <a:pPr indent="0" marL="0">
+              <a:buNone/>
+            </a:pPr>
+            <a:r>
+              <a:rPr lang="en-US" sz="3600" b="1" dirty="0">
+                <a:solidFill>
+                  <a:srgbClr val="1A2744"/>
+                </a:solidFill>
+                <a:latin typeface="Cambria" pitchFamily="34" charset="0"/>
+                <a:ea typeface="Cambria" pitchFamily="34" charset="-122"/>
+                <a:cs typeface="Cambria" pitchFamily="34" charset="-120"/>
+              </a:rPr>
+              <a:t>Replacement/Silent Mutation Ratio</a:t>
+            </a:r>
+            <a:endParaRPr lang="en-US" sz="3600" dirty="0"/>
+          </a:p>
+        </p:txBody>
+      </p:sp>
+      <p:sp>
+        <p:nvSpPr>
+          <p:cNvPr id="3" name="Text 1"/>
+          <p:cNvSpPr/>
+          <p:nvPr/>
+        </p:nvSpPr>
+        <p:spPr>
+          <a:xfrm>
+            <a:off x="731520" y="914400"/>
+            <a:ext cx="10515600" cy="365760"/>
+          </a:xfrm>
+          <a:prstGeom prst="rect">
+            <a:avLst/>
+          </a:prstGeom>
+          <a:noFill/>
+          <a:ln/>
+        </p:spPr>
+        <p:txBody>
+          <a:bodyPr wrap="square" rtlCol="0" anchor="ctr"/>
+          <a:lstStyle/>
+          <a:p>
+            <a:pPr indent="0" marL="0">
+              <a:buNone/>
+            </a:pPr>
+            <a:r>
+              <a:rPr lang="en-US" sz="1400" i="1" dirty="0">
+                <a:solidFill>
+                  <a:srgbClr val="4A5568"/>
+                </a:solidFill>
+                <a:latin typeface="Calibri" pitchFamily="34" charset="0"/>
+                <a:ea typeface="Calibri" pitchFamily="34" charset="-122"/>
+                <a:cs typeface="Calibri" pitchFamily="34" charset="-120"/>
+              </a:rPr>
+              <a:t>R/S ratio as a measure of antigen-driven selection pressure</a:t>
+            </a:r>
+            <a:endParaRPr lang="en-US" sz="1400" dirty="0"/>
+          </a:p>
+        </p:txBody>
+      </p:sp>
+      <p:pic>
+        <p:nvPicPr>
+          <p:cNvPr id="4" name="Image 0" descr="preencoded.png">    </p:cNvPr>
+          <p:cNvPicPr>
+            <a:picLocks noChangeAspect="1"/>
+          </p:cNvPicPr>
+          <p:nvPr/>
+        </p:nvPicPr>
+        <p:blipFill>
+          <a:blip r:embed="rId1"/>
+          <a:stretch>
+            <a:fillRect/>
+          </a:stretch>
+        </p:blipFill>
+        <p:spPr>
+          <a:xfrm>
+            <a:off x="274320" y="1371600"/>
+            <a:ext cx="6858000" cy="4572000"/>
+          </a:xfrm>
+          <a:prstGeom prst="rect">
+            <a:avLst/>
+          </a:prstGeom>
+        </p:spPr>
+      </p:pic>
+      <p:sp>
+        <p:nvSpPr>
+          <p:cNvPr id="5" name="Shape 2"/>
+          <p:cNvSpPr/>
+          <p:nvPr/>
+        </p:nvSpPr>
+        <p:spPr>
+          <a:xfrm>
+            <a:off x="7498080" y="1371600"/>
+            <a:ext cx="4206240" cy="4389120"/>
+          </a:xfrm>
+          <a:prstGeom prst="roundRect">
+            <a:avLst>
+              <a:gd name="adj" fmla="val 3261"/>
+            </a:avLst>
+          </a:prstGeom>
+          <a:solidFill>
+            <a:srgbClr val="F0F4F8"/>
+          </a:solidFill>
+          <a:ln/>
+        </p:spPr>
+      </p:sp>
+      <p:sp>
+        <p:nvSpPr>
+          <p:cNvPr id="6" name="Text 3"/>
+          <p:cNvSpPr/>
+          <p:nvPr/>
+        </p:nvSpPr>
+        <p:spPr>
+          <a:xfrm>
+            <a:off x="7680960" y="1554480"/>
+            <a:ext cx="3840480" cy="365760"/>
+          </a:xfrm>
+          <a:prstGeom prst="rect">
+            <a:avLst/>
+          </a:prstGeom>
+          <a:noFill/>
+          <a:ln/>
+        </p:spPr>
+        <p:txBody>
+          <a:bodyPr wrap="square" lIns="0" tIns="0" rIns="0" bIns="0" rtlCol="0" anchor="ctr"/>
+          <a:lstStyle/>
+          <a:p>
+            <a:pPr indent="0" marL="0">
+              <a:buNone/>
+            </a:pPr>
+            <a:r>
+              <a:rPr lang="en-US" sz="1600" b="1" dirty="0">
+                <a:solidFill>
+                  <a:srgbClr val="1A2744"/>
+                </a:solidFill>
+                <a:latin typeface="Calibri" pitchFamily="34" charset="0"/>
+                <a:ea typeface="Calibri" pitchFamily="34" charset="-122"/>
+                <a:cs typeface="Calibri" pitchFamily="34" charset="-120"/>
+              </a:rPr>
+              <a:t>Key Findings</a:t>
+            </a:r>
+            <a:endParaRPr lang="en-US" sz="1600" dirty="0"/>
+          </a:p>
+        </p:txBody>
+      </p:sp>
+      <p:sp>
+        <p:nvSpPr>
+          <p:cNvPr id="7" name="Text 4"/>
+          <p:cNvSpPr/>
+          <p:nvPr/>
+        </p:nvSpPr>
+        <p:spPr>
+          <a:xfrm>
+            <a:off x="7680960" y="2103120"/>
+            <a:ext cx="3840480" cy="640080"/>
+          </a:xfrm>
+          <a:prstGeom prst="rect">
+            <a:avLst/>
+          </a:prstGeom>
+          <a:noFill/>
+          <a:ln/>
+        </p:spPr>
+        <p:txBody>
+          <a:bodyPr wrap="square" lIns="0" tIns="0" rIns="0" bIns="0" rtlCol="0" anchor="ctr"/>
+          <a:lstStyle/>
+          <a:p>
+            <a:pPr marL="342900" indent="-342900">
+              <a:spcAft>
+                <a:spcPts val="400"/>
+              </a:spcAft>
+              <a:buSzPct val="100000"/>
+              <a:buChar char="•"/>
+            </a:pPr>
+            <a:r>
+              <a:rPr lang="en-US" sz="1200" dirty="0">
+                <a:solidFill>
+                  <a:srgbClr val="4A5568"/>
+                </a:solidFill>
+                <a:latin typeface="Calibri" pitchFamily="34" charset="0"/>
+                <a:ea typeface="Calibri" pitchFamily="34" charset="-122"/>
+                <a:cs typeface="Calibri" pitchFamily="34" charset="-120"/>
+              </a:rPr>
+              <a:t>R/S ratio &gt; 1 indicates positive selection — replacement mutations are favored over silent ones</a:t>
+            </a:r>
+            <a:endParaRPr lang="en-US" sz="1200" dirty="0"/>
+          </a:p>
+        </p:txBody>
+      </p:sp>
+      <p:sp>
+        <p:nvSpPr>
+          <p:cNvPr id="8" name="Text 5"/>
+          <p:cNvSpPr/>
+          <p:nvPr/>
+        </p:nvSpPr>
+        <p:spPr>
+          <a:xfrm>
+            <a:off x="7680960" y="2834640"/>
+            <a:ext cx="3840480" cy="640080"/>
+          </a:xfrm>
+          <a:prstGeom prst="rect">
+            <a:avLst/>
+          </a:prstGeom>
+          <a:noFill/>
+          <a:ln/>
+        </p:spPr>
+        <p:txBody>
+          <a:bodyPr wrap="square" lIns="0" tIns="0" rIns="0" bIns="0" rtlCol="0" anchor="ctr"/>
+          <a:lstStyle/>
+          <a:p>
+            <a:pPr marL="342900" indent="-342900">
+              <a:spcAft>
+                <a:spcPts val="400"/>
+              </a:spcAft>
+              <a:buSzPct val="100000"/>
+              <a:buChar char="•"/>
+            </a:pPr>
+            <a:r>
+              <a:rPr lang="en-US" sz="1200" dirty="0">
+                <a:solidFill>
+                  <a:srgbClr val="4A5568"/>
+                </a:solidFill>
+                <a:latin typeface="Calibri" pitchFamily="34" charset="0"/>
+                <a:ea typeface="Calibri" pitchFamily="34" charset="-122"/>
+                <a:cs typeface="Calibri" pitchFamily="34" charset="-120"/>
+              </a:rPr>
+              <a:t>Higher R/S in CDR regions vs framework reflects antigen-driven selection in binding sites</a:t>
+            </a:r>
+            <a:endParaRPr lang="en-US" sz="1200" dirty="0"/>
+          </a:p>
+        </p:txBody>
+      </p:sp>
+      <p:sp>
+        <p:nvSpPr>
+          <p:cNvPr id="9" name="Text 6"/>
+          <p:cNvSpPr/>
+          <p:nvPr/>
+        </p:nvSpPr>
+        <p:spPr>
+          <a:xfrm>
+            <a:off x="7680960" y="3566160"/>
+            <a:ext cx="3840480" cy="640080"/>
+          </a:xfrm>
+          <a:prstGeom prst="rect">
+            <a:avLst/>
+          </a:prstGeom>
+          <a:noFill/>
+          <a:ln/>
+        </p:spPr>
+        <p:txBody>
+          <a:bodyPr wrap="square" lIns="0" tIns="0" rIns="0" bIns="0" rtlCol="0" anchor="ctr"/>
+          <a:lstStyle/>
+          <a:p>
+            <a:pPr marL="342900" indent="-342900">
+              <a:spcAft>
+                <a:spcPts val="400"/>
+              </a:spcAft>
+              <a:buSzPct val="100000"/>
+              <a:buChar char="•"/>
+            </a:pPr>
+            <a:r>
+              <a:rPr lang="en-US" sz="1200" dirty="0">
+                <a:solidFill>
+                  <a:srgbClr val="4A5568"/>
+                </a:solidFill>
+                <a:latin typeface="Calibri" pitchFamily="34" charset="0"/>
+                <a:ea typeface="Calibri" pitchFamily="34" charset="-122"/>
+                <a:cs typeface="Calibri" pitchFamily="34" charset="-120"/>
+              </a:rPr>
+              <a:t>COVID Naive and Recovered groups show elevated R/S ratios consistent with affinity maturation</a:t>
+            </a:r>
+            <a:endParaRPr lang="en-US" sz="1200" dirty="0"/>
+          </a:p>
+        </p:txBody>
+      </p:sp>
+      <p:sp>
+        <p:nvSpPr>
+          <p:cNvPr id="10" name="Text 7"/>
+          <p:cNvSpPr/>
+          <p:nvPr/>
+        </p:nvSpPr>
+        <p:spPr>
+          <a:xfrm>
+            <a:off x="7680960" y="4297680"/>
+            <a:ext cx="3840480" cy="640080"/>
+          </a:xfrm>
+          <a:prstGeom prst="rect">
+            <a:avLst/>
+          </a:prstGeom>
+          <a:noFill/>
+          <a:ln/>
+        </p:spPr>
+        <p:txBody>
+          <a:bodyPr wrap="square" lIns="0" tIns="0" rIns="0" bIns="0" rtlCol="0" anchor="ctr"/>
+          <a:lstStyle/>
+          <a:p>
+            <a:pPr marL="342900" indent="-342900">
+              <a:spcAft>
+                <a:spcPts val="400"/>
+              </a:spcAft>
+              <a:buSzPct val="100000"/>
+              <a:buChar char="•"/>
+            </a:pPr>
+            <a:r>
+              <a:rPr lang="en-US" sz="1200" dirty="0">
+                <a:solidFill>
+                  <a:srgbClr val="4A5568"/>
+                </a:solidFill>
+                <a:latin typeface="Calibri" pitchFamily="34" charset="0"/>
+                <a:ea typeface="Calibri" pitchFamily="34" charset="-122"/>
+                <a:cs typeface="Calibri" pitchFamily="34" charset="-120"/>
+              </a:rPr>
+              <a:t>Healthy controls show baseline R/S levels expected for unselected repertoires</a:t>
+            </a:r>
+            <a:endParaRPr lang="en-US" sz="1200" dirty="0"/>
+          </a:p>
+        </p:txBody>
+      </p:sp>
+    </p:spTree>
+  </p:cSld>
+  <p:clrMapOvr>
+    <a:masterClrMapping/>
+  </p:clrMapOvr>
+</p:sld>
+</file>
+
+<file path=ppt/slides/slide11.xml><?xml version="1.0" encoding="utf-8"?>
+<p:sld xmlns:a="http://schemas.openxmlformats.org/drawingml/2006/main" xmlns:r="http://schemas.openxmlformats.org/officeDocument/2006/relationships" xmlns:p="http://schemas.openxmlformats.org/presentationml/2006/main">
+  <p:cSld name="Slide 11">
+    <p:bg>
+      <p:bgPr>
+        <a:solidFill>
+          <a:srgbClr val="FFFFFF"/>
+        </a:solidFill>
+      </p:bgPr>
+    </p:bg>
+    <p:spTree>
+      <p:nvGrpSpPr>
+        <p:cNvPr id="1" name=""/>
+        <p:cNvGrpSpPr/>
+        <p:nvPr/>
+      </p:nvGrpSpPr>
+      <p:grpSpPr>
+        <a:xfrm>
+          <a:off x="0" y="0"/>
+          <a:ext cx="0" cy="0"/>
+          <a:chOff x="0" y="0"/>
+          <a:chExt cx="0" cy="0"/>
+        </a:xfrm>
+      </p:grpSpPr>
+      <p:sp>
+        <p:nvSpPr>
+          <p:cNvPr id="2" name="Text 0"/>
+          <p:cNvSpPr/>
+          <p:nvPr/>
+        </p:nvSpPr>
+        <p:spPr>
+          <a:xfrm>
+            <a:off x="731520" y="274320"/>
+            <a:ext cx="10515600" cy="731520"/>
+          </a:xfrm>
+          <a:prstGeom prst="rect">
+            <a:avLst/>
+          </a:prstGeom>
+          <a:noFill/>
+          <a:ln/>
+        </p:spPr>
+        <p:txBody>
+          <a:bodyPr wrap="square" rtlCol="0" anchor="ctr"/>
+          <a:lstStyle/>
+          <a:p>
+            <a:pPr indent="0" marL="0">
+              <a:buNone/>
+            </a:pPr>
+            <a:r>
+              <a:rPr lang="en-US" sz="3600" b="1" dirty="0">
+                <a:solidFill>
+                  <a:srgbClr val="1A2744"/>
+                </a:solidFill>
+                <a:latin typeface="Cambria" pitchFamily="34" charset="0"/>
+                <a:ea typeface="Cambria" pitchFamily="34" charset="-122"/>
+                <a:cs typeface="Cambria" pitchFamily="34" charset="-120"/>
+              </a:rPr>
+              <a:t>Somatic Hypermutation Analysis</a:t>
+            </a:r>
+            <a:endParaRPr lang="en-US" sz="3600" dirty="0"/>
+          </a:p>
+        </p:txBody>
+      </p:sp>
+      <p:pic>
+        <p:nvPicPr>
+          <p:cNvPr id="3" name="Image 0" descr="preencoded.png">    </p:cNvPr>
+          <p:cNvPicPr>
+            <a:picLocks noChangeAspect="1"/>
+          </p:cNvPicPr>
+          <p:nvPr/>
+        </p:nvPicPr>
+        <p:blipFill>
+          <a:blip r:embed="rId1"/>
+          <a:stretch>
+            <a:fillRect/>
+          </a:stretch>
+        </p:blipFill>
+        <p:spPr>
+          <a:xfrm>
+            <a:off x="274320" y="1097280"/>
+            <a:ext cx="5486400" cy="3657600"/>
+          </a:xfrm>
+          <a:prstGeom prst="rect">
+            <a:avLst/>
+          </a:prstGeom>
+        </p:spPr>
+      </p:pic>
+      <p:pic>
+        <p:nvPicPr>
+          <p:cNvPr id="4" name="Image 1" descr="preencoded.png">    </p:cNvPr>
+          <p:cNvPicPr>
+            <a:picLocks noChangeAspect="1"/>
+          </p:cNvPicPr>
+          <p:nvPr/>
+        </p:nvPicPr>
+        <p:blipFill>
+          <a:blip r:embed="rId2"/>
+          <a:stretch>
+            <a:fillRect/>
+          </a:stretch>
+        </p:blipFill>
+        <p:spPr>
+          <a:xfrm>
+            <a:off x="5943600" y="1097280"/>
+            <a:ext cx="5486400" cy="3657600"/>
+          </a:xfrm>
+          <a:prstGeom prst="rect">
+            <a:avLst/>
+          </a:prstGeom>
+        </p:spPr>
+      </p:pic>
+      <p:sp>
+        <p:nvSpPr>
+          <p:cNvPr id="5" name="Text 1"/>
+          <p:cNvSpPr/>
+          <p:nvPr/>
+        </p:nvSpPr>
+        <p:spPr>
+          <a:xfrm>
+            <a:off x="457200" y="4754880"/>
+            <a:ext cx="5303520" cy="274320"/>
+          </a:xfrm>
+          <a:prstGeom prst="rect">
+            <a:avLst/>
+          </a:prstGeom>
+          <a:noFill/>
+          <a:ln/>
+        </p:spPr>
+        <p:txBody>
+          <a:bodyPr wrap="square" rtlCol="0" anchor="ctr"/>
+          <a:lstStyle/>
+          <a:p>
+            <a:pPr algn="ctr" indent="0" marL="0">
+              <a:buNone/>
+            </a:pPr>
+            <a:r>
+              <a:rPr lang="en-US" sz="1100" i="1" dirty="0">
+                <a:solidFill>
+                  <a:srgbClr val="718096"/>
+                </a:solidFill>
+                <a:latin typeface="Calibri" pitchFamily="34" charset="0"/>
+                <a:ea typeface="Calibri" pitchFamily="34" charset="-122"/>
+                <a:cs typeface="Calibri" pitchFamily="34" charset="-120"/>
+              </a:rPr>
+              <a:t>Mutation Count (Top 10 Clones)</a:t>
+            </a:r>
+            <a:endParaRPr lang="en-US" sz="1100" dirty="0"/>
+          </a:p>
+        </p:txBody>
+      </p:sp>
+      <p:sp>
+        <p:nvSpPr>
+          <p:cNvPr id="6" name="Text 2"/>
+          <p:cNvSpPr/>
+          <p:nvPr/>
+        </p:nvSpPr>
+        <p:spPr>
+          <a:xfrm>
+            <a:off x="6126480" y="4754880"/>
+            <a:ext cx="5303520" cy="274320"/>
+          </a:xfrm>
+          <a:prstGeom prst="rect">
+            <a:avLst/>
+          </a:prstGeom>
+          <a:noFill/>
+          <a:ln/>
+        </p:spPr>
+        <p:txBody>
+          <a:bodyPr wrap="square" rtlCol="0" anchor="ctr"/>
+          <a:lstStyle/>
+          <a:p>
+            <a:pPr algn="ctr" indent="0" marL="0">
+              <a:buNone/>
+            </a:pPr>
+            <a:r>
+              <a:rPr lang="en-US" sz="1100" i="1" dirty="0">
+                <a:solidFill>
+                  <a:srgbClr val="718096"/>
+                </a:solidFill>
+                <a:latin typeface="Calibri" pitchFamily="34" charset="0"/>
+                <a:ea typeface="Calibri" pitchFamily="34" charset="-122"/>
+                <a:cs typeface="Calibri" pitchFamily="34" charset="-120"/>
+              </a:rPr>
+              <a:t>CDR Region Mutations</a:t>
+            </a:r>
+            <a:endParaRPr lang="en-US" sz="1100" dirty="0"/>
+          </a:p>
+        </p:txBody>
+      </p:sp>
+      <p:sp>
+        <p:nvSpPr>
+          <p:cNvPr id="7" name="Shape 3"/>
+          <p:cNvSpPr/>
+          <p:nvPr/>
+        </p:nvSpPr>
+        <p:spPr>
+          <a:xfrm>
+            <a:off x="731520" y="5120640"/>
+            <a:ext cx="10515600" cy="1097280"/>
+          </a:xfrm>
+          <a:prstGeom prst="roundRect">
+            <a:avLst>
+              <a:gd name="adj" fmla="val 8333"/>
+            </a:avLst>
+          </a:prstGeom>
+          <a:solidFill>
+            <a:srgbClr val="F0F4F8"/>
+          </a:solidFill>
+          <a:ln/>
+        </p:spPr>
+      </p:sp>
+      <p:sp>
+        <p:nvSpPr>
+          <p:cNvPr id="8" name="Text 4"/>
+          <p:cNvSpPr/>
+          <p:nvPr/>
+        </p:nvSpPr>
+        <p:spPr>
+          <a:xfrm>
+            <a:off x="914400" y="5212080"/>
+            <a:ext cx="10149840" cy="914400"/>
+          </a:xfrm>
+          <a:prstGeom prst="rect">
+            <a:avLst/>
+          </a:prstGeom>
+          <a:noFill/>
+          <a:ln/>
+        </p:spPr>
+        <p:txBody>
+          <a:bodyPr wrap="square" lIns="0" tIns="0" rIns="0" bIns="0" rtlCol="0" anchor="ctr"/>
+          <a:lstStyle/>
+          <a:p>
+            <a:pPr indent="0" marL="0">
+              <a:buNone/>
+            </a:pPr>
+            <a:r>
+              <a:rPr lang="en-US" sz="1300" dirty="0">
+                <a:solidFill>
+                  <a:srgbClr val="4A5568"/>
+                </a:solidFill>
+                <a:latin typeface="Calibri" pitchFamily="34" charset="0"/>
+                <a:ea typeface="Calibri" pitchFamily="34" charset="-122"/>
+                <a:cs typeface="Calibri" pitchFamily="34" charset="-120"/>
+              </a:rPr>
+              <a:t>Mutation counts represent unique nucleotide positions differing from germline. Higher mutation in COVID Naive and Recovered groups suggests mature, affinity-selected B cell responses. CDR mutations indicate antigen-driven selection.</a:t>
+            </a:r>
+            <a:endParaRPr lang="en-US" sz="1300" dirty="0"/>
+          </a:p>
+        </p:txBody>
+      </p:sp>
+    </p:spTree>
+  </p:cSld>
+  <p:clrMapOvr>
+    <a:masterClrMapping/>
+  </p:clrMapOvr>
+</p:sld>
+</file>
+
+<file path=ppt/slides/slide12.xml><?xml version="1.0" encoding="utf-8"?>
+<p:sld xmlns:a="http://schemas.openxmlformats.org/drawingml/2006/main" xmlns:r="http://schemas.openxmlformats.org/officeDocument/2006/relationships" xmlns:p="http://schemas.openxmlformats.org/presentationml/2006/main">
+  <p:cSld name="Slide 12">
+    <p:bg>
+      <p:bgPr>
+        <a:solidFill>
+          <a:srgbClr val="FFFFFF"/>
+        </a:solidFill>
+      </p:bgPr>
+    </p:bg>
+    <p:spTree>
+      <p:nvGrpSpPr>
+        <p:cNvPr id="1" name=""/>
+        <p:cNvGrpSpPr/>
+        <p:nvPr/>
+      </p:nvGrpSpPr>
+      <p:grpSpPr>
+        <a:xfrm>
+          <a:off x="0" y="0"/>
+          <a:ext cx="0" cy="0"/>
+          <a:chOff x="0" y="0"/>
+          <a:chExt cx="0" cy="0"/>
+        </a:xfrm>
+      </p:grpSpPr>
+      <p:sp>
+        <p:nvSpPr>
+          <p:cNvPr id="2" name="Text 0"/>
+          <p:cNvSpPr/>
+          <p:nvPr/>
+        </p:nvSpPr>
+        <p:spPr>
+          <a:xfrm>
+            <a:off x="731520" y="274320"/>
+            <a:ext cx="10515600" cy="731520"/>
+          </a:xfrm>
+          <a:prstGeom prst="rect">
+            <a:avLst/>
+          </a:prstGeom>
+          <a:noFill/>
+          <a:ln/>
+        </p:spPr>
+        <p:txBody>
+          <a:bodyPr wrap="square" rtlCol="0" anchor="ctr"/>
+          <a:lstStyle/>
+          <a:p>
+            <a:pPr indent="0" marL="0">
+              <a:buNone/>
+            </a:pPr>
+            <a:r>
+              <a:rPr lang="en-US" sz="3600" b="1" dirty="0">
+                <a:solidFill>
+                  <a:srgbClr val="1A2744"/>
+                </a:solidFill>
+                <a:latin typeface="Cambria" pitchFamily="34" charset="0"/>
+                <a:ea typeface="Cambria" pitchFamily="34" charset="-122"/>
+                <a:cs typeface="Cambria" pitchFamily="34" charset="-120"/>
+              </a:rPr>
+              <a:t>CDR3 Length Analysis</a:t>
+            </a:r>
+            <a:endParaRPr lang="en-US" sz="3600" dirty="0"/>
+          </a:p>
+        </p:txBody>
+      </p:sp>
+      <p:pic>
+        <p:nvPicPr>
+          <p:cNvPr id="3" name="Image 0" descr="preencoded.png">    </p:cNvPr>
+          <p:cNvPicPr>
+            <a:picLocks noChangeAspect="1"/>
+          </p:cNvPicPr>
+          <p:nvPr/>
+        </p:nvPicPr>
+        <p:blipFill>
+          <a:blip r:embed="rId1"/>
+          <a:stretch>
+            <a:fillRect/>
+          </a:stretch>
+        </p:blipFill>
+        <p:spPr>
+          <a:xfrm>
+            <a:off x="274320" y="1097280"/>
+            <a:ext cx="5486400" cy="3657600"/>
+          </a:xfrm>
+          <a:prstGeom prst="rect">
+            <a:avLst/>
+          </a:prstGeom>
+        </p:spPr>
+      </p:pic>
+      <p:pic>
+        <p:nvPicPr>
+          <p:cNvPr id="4" name="Image 1" descr="preencoded.png">    </p:cNvPr>
+          <p:cNvPicPr>
+            <a:picLocks noChangeAspect="1"/>
+          </p:cNvPicPr>
+          <p:nvPr/>
+        </p:nvPicPr>
+        <p:blipFill>
+          <a:blip r:embed="rId2"/>
+          <a:stretch>
+            <a:fillRect/>
+          </a:stretch>
+        </p:blipFill>
+        <p:spPr>
+          <a:xfrm>
+            <a:off x="5943600" y="1097280"/>
+            <a:ext cx="5486400" cy="3657600"/>
+          </a:xfrm>
+          <a:prstGeom prst="rect">
+            <a:avLst/>
+          </a:prstGeom>
+        </p:spPr>
+      </p:pic>
+      <p:sp>
+        <p:nvSpPr>
+          <p:cNvPr id="5" name="Text 1"/>
+          <p:cNvSpPr/>
+          <p:nvPr/>
+        </p:nvSpPr>
+        <p:spPr>
+          <a:xfrm>
+            <a:off x="457200" y="4754880"/>
+            <a:ext cx="5303520" cy="274320"/>
+          </a:xfrm>
+          <a:prstGeom prst="rect">
+            <a:avLst/>
+          </a:prstGeom>
+          <a:noFill/>
+          <a:ln/>
+        </p:spPr>
+        <p:txBody>
+          <a:bodyPr wrap="square" rtlCol="0" anchor="ctr"/>
+          <a:lstStyle/>
+          <a:p>
+            <a:pPr algn="ctr" indent="0" marL="0">
+              <a:buNone/>
+            </a:pPr>
+            <a:r>
+              <a:rPr lang="en-US" sz="1100" i="1" dirty="0">
+                <a:solidFill>
+                  <a:srgbClr val="718096"/>
+                </a:solidFill>
+                <a:latin typeface="Calibri" pitchFamily="34" charset="0"/>
+                <a:ea typeface="Calibri" pitchFamily="34" charset="-122"/>
+                <a:cs typeface="Calibri" pitchFamily="34" charset="-120"/>
+              </a:rPr>
+              <a:t>CDR3 Length (Top 10 Clones, AA)</a:t>
+            </a:r>
+            <a:endParaRPr lang="en-US" sz="1100" dirty="0"/>
+          </a:p>
+        </p:txBody>
+      </p:sp>
+      <p:sp>
+        <p:nvSpPr>
+          <p:cNvPr id="6" name="Text 2"/>
+          <p:cNvSpPr/>
+          <p:nvPr/>
+        </p:nvSpPr>
+        <p:spPr>
+          <a:xfrm>
+            <a:off x="6126480" y="4754880"/>
+            <a:ext cx="5303520" cy="274320"/>
+          </a:xfrm>
+          <a:prstGeom prst="rect">
+            <a:avLst/>
+          </a:prstGeom>
+          <a:noFill/>
+          <a:ln/>
+        </p:spPr>
+        <p:txBody>
+          <a:bodyPr wrap="square" rtlCol="0" anchor="ctr"/>
+          <a:lstStyle/>
+          <a:p>
+            <a:pPr algn="ctr" indent="0" marL="0">
+              <a:buNone/>
+            </a:pPr>
+            <a:r>
+              <a:rPr lang="en-US" sz="1100" i="1" dirty="0">
+                <a:solidFill>
+                  <a:srgbClr val="718096"/>
+                </a:solidFill>
+                <a:latin typeface="Calibri" pitchFamily="34" charset="0"/>
+                <a:ea typeface="Calibri" pitchFamily="34" charset="-122"/>
+                <a:cs typeface="Calibri" pitchFamily="34" charset="-120"/>
+              </a:rPr>
+              <a:t>CDR3 Length Range per Subject</a:t>
+            </a:r>
+            <a:endParaRPr lang="en-US" sz="1100" dirty="0"/>
+          </a:p>
+        </p:txBody>
+      </p:sp>
+      <p:sp>
+        <p:nvSpPr>
+          <p:cNvPr id="7" name="Shape 3"/>
+          <p:cNvSpPr/>
+          <p:nvPr/>
+        </p:nvSpPr>
+        <p:spPr>
+          <a:xfrm>
+            <a:off x="731520" y="5120640"/>
+            <a:ext cx="10515600" cy="1097280"/>
+          </a:xfrm>
+          <a:prstGeom prst="roundRect">
+            <a:avLst>
+              <a:gd name="adj" fmla="val 8333"/>
+            </a:avLst>
+          </a:prstGeom>
+          <a:solidFill>
+            <a:srgbClr val="F0F4F8"/>
+          </a:solidFill>
+          <a:ln/>
+        </p:spPr>
+      </p:sp>
+      <p:sp>
+        <p:nvSpPr>
+          <p:cNvPr id="8" name="Text 4"/>
+          <p:cNvSpPr/>
+          <p:nvPr/>
+        </p:nvSpPr>
+        <p:spPr>
+          <a:xfrm>
+            <a:off x="914400" y="5212080"/>
+            <a:ext cx="10149840" cy="914400"/>
+          </a:xfrm>
+          <a:prstGeom prst="rect">
+            <a:avLst/>
+          </a:prstGeom>
+          <a:noFill/>
+          <a:ln/>
+        </p:spPr>
+        <p:txBody>
+          <a:bodyPr wrap="square" lIns="0" tIns="0" rIns="0" bIns="0" rtlCol="0" anchor="ctr"/>
+          <a:lstStyle/>
+          <a:p>
+            <a:pPr indent="0" marL="0">
+              <a:buNone/>
+            </a:pPr>
+            <a:r>
+              <a:rPr lang="en-US" sz="1300" dirty="0">
+                <a:solidFill>
+                  <a:srgbClr val="4A5568"/>
+                </a:solidFill>
+                <a:latin typeface="Calibri" pitchFamily="34" charset="0"/>
+                <a:ea typeface="Calibri" pitchFamily="34" charset="-122"/>
+                <a:cs typeface="Calibri" pitchFamily="34" charset="-120"/>
+              </a:rPr>
+              <a:t>CDR3 lengths are relatively consistent across disease categories (~15–16 AA for top clones), suggesting the overall structural constraints on antigen binding are preserved. Greater CDR3 range diversity is observed in COVID Naive and Recovered groups.</a:t>
+            </a:r>
+            <a:endParaRPr lang="en-US" sz="1300" dirty="0"/>
+          </a:p>
+        </p:txBody>
+      </p:sp>
+    </p:spTree>
+  </p:cSld>
+  <p:clrMapOvr>
+    <a:masterClrMapping/>
+  </p:clrMapOvr>
+</p:sld>
+</file>
+
+<file path=ppt/slides/slide13.xml><?xml version="1.0" encoding="utf-8"?>
+<p:sld xmlns:a="http://schemas.openxmlformats.org/drawingml/2006/main" xmlns:r="http://schemas.openxmlformats.org/officeDocument/2006/relationships" xmlns:p="http://schemas.openxmlformats.org/presentationml/2006/main">
+  <p:cSld name="Slide 13">
+    <p:bg>
+      <p:bgPr>
+        <a:solidFill>
           <a:srgbClr val="1A2744"/>
         </a:solidFill>
       </p:bgPr>
@@ -6619,15 +7769,54 @@
                 <a:ea typeface="Cambria" pitchFamily="34" charset="-122"/>
                 <a:cs typeface="Cambria" pitchFamily="34" charset="-120"/>
               </a:rPr>
-              <a:t>Somatic Hypermutation Analysis</a:t>
+              <a:t>Clone Count by Disease Category</a:t>
             </a:r>
             <a:endParaRPr lang="en-US" sz="3600" dirty="0"/>
+          </a:p>
+        </p:txBody>
+      </p:sp>
+      <p:sp>
+        <p:nvSpPr>
+          <p:cNvPr id="3" name="Text 1"/>
+          <p:cNvSpPr/>
+          <p:nvPr/>
+        </p:nvSpPr>
+        <p:spPr>
+          <a:xfrm>
+            <a:off x="731520" y="914400"/>
+            <a:ext cx="10515600" cy="365760"/>
+          </a:xfrm>
+          <a:prstGeom prst="rect">
+            <a:avLst/>
+          </a:prstGeom>
+          <a:noFill/>
+          <a:ln/>
+        </p:spPr>
+        <p:txBody>
+          <a:bodyPr wrap="square" rtlCol="0" anchor="ctr"/>
+          <a:lstStyle/>
+          <a:p>
+            <a:pPr indent="0" marL="0">
+              <a:buNone/>
+            </a:pPr>
+            <a:r>
+              <a:rPr lang="en-US" sz="1400" i="1" dirty="0">
+                <a:solidFill>
+                  <a:srgbClr val="4A5568"/>
+                </a:solidFill>
+                <a:latin typeface="Calibri" pitchFamily="34" charset="0"/>
+                <a:ea typeface="Calibri" pitchFamily="34" charset="-122"/>
+                <a:cs typeface="Calibri" pitchFamily="34" charset="-120"/>
+              </a:rPr>
+              <a:t>Number of distinct clones per subject across disease severities</a:t>
+            </a:r>
+            <a:endParaRPr lang="en-US" sz="1400" dirty="0"/>
           </a:p>
         </p:txBody>
       </p:sp>
       <p:pic>
         <p:nvPicPr>
-          <p:cNvPr id="3" name="Image 0" descr="preencoded.png">    </p:cNvPr>
+          <p:cNvPr id="4" name="Image 0" descr="preencoded.png">    </p:cNvPr>
           <p:cNvPicPr>
             <a:picLocks noChangeAspect="1"/>
           </p:cNvPicPr>
@@ -6641,130 +7830,28 @@
         </p:blipFill>
         <p:spPr>
           <a:xfrm>
-            <a:off x="274320" y="1097280"/>
-            <a:ext cx="5486400" cy="3657600"/>
+            <a:off x="274320" y="1371600"/>
+            <a:ext cx="6858000" cy="4572000"/>
           </a:xfrm>
           <a:prstGeom prst="rect">
             <a:avLst/>
           </a:prstGeom>
         </p:spPr>
       </p:pic>
-      <p:pic>
-        <p:nvPicPr>
-          <p:cNvPr id="4" name="Image 1" descr="preencoded.png">    </p:cNvPr>
-          <p:cNvPicPr>
-            <a:picLocks noChangeAspect="1"/>
-          </p:cNvPicPr>
-          <p:nvPr/>
-        </p:nvPicPr>
-        <p:blipFill>
-          <a:blip r:embed="rId2"/>
-          <a:stretch>
-            <a:fillRect/>
-          </a:stretch>
-        </p:blipFill>
-        <p:spPr>
-          <a:xfrm>
-            <a:off x="5943600" y="1097280"/>
-            <a:ext cx="5486400" cy="3657600"/>
-          </a:xfrm>
-          <a:prstGeom prst="rect">
-            <a:avLst/>
-          </a:prstGeom>
-        </p:spPr>
-      </p:pic>
-      <p:sp>
-        <p:nvSpPr>
-          <p:cNvPr id="5" name="Text 1"/>
-          <p:cNvSpPr/>
-          <p:nvPr/>
-        </p:nvSpPr>
-        <p:spPr>
-          <a:xfrm>
-            <a:off x="457200" y="4754880"/>
-            <a:ext cx="5303520" cy="274320"/>
-          </a:xfrm>
-          <a:prstGeom prst="rect">
-            <a:avLst/>
-          </a:prstGeom>
-          <a:noFill/>
-          <a:ln/>
-        </p:spPr>
-        <p:txBody>
-          <a:bodyPr wrap="square" rtlCol="0" anchor="ctr"/>
-          <a:lstStyle/>
-          <a:p>
-            <a:pPr algn="ctr" indent="0" marL="0">
-              <a:buNone/>
-            </a:pPr>
-            <a:r>
-              <a:rPr lang="en-US" sz="1100" i="1" dirty="0">
-                <a:solidFill>
-                  <a:srgbClr val="718096"/>
-                </a:solidFill>
-                <a:latin typeface="Calibri" pitchFamily="34" charset="0"/>
-                <a:ea typeface="Calibri" pitchFamily="34" charset="-122"/>
-                <a:cs typeface="Calibri" pitchFamily="34" charset="-120"/>
-              </a:rPr>
-              <a:t>Mutation Count (Top 10 Clones)</a:t>
-            </a:r>
-            <a:endParaRPr lang="en-US" sz="1100" dirty="0"/>
-          </a:p>
-        </p:txBody>
-      </p:sp>
-      <p:sp>
-        <p:nvSpPr>
-          <p:cNvPr id="6" name="Text 2"/>
-          <p:cNvSpPr/>
-          <p:nvPr/>
-        </p:nvSpPr>
-        <p:spPr>
-          <a:xfrm>
-            <a:off x="6126480" y="4754880"/>
-            <a:ext cx="5303520" cy="274320"/>
-          </a:xfrm>
-          <a:prstGeom prst="rect">
-            <a:avLst/>
-          </a:prstGeom>
-          <a:noFill/>
-          <a:ln/>
-        </p:spPr>
-        <p:txBody>
-          <a:bodyPr wrap="square" rtlCol="0" anchor="ctr"/>
-          <a:lstStyle/>
-          <a:p>
-            <a:pPr algn="ctr" indent="0" marL="0">
-              <a:buNone/>
-            </a:pPr>
-            <a:r>
-              <a:rPr lang="en-US" sz="1100" i="1" dirty="0">
-                <a:solidFill>
-                  <a:srgbClr val="718096"/>
-                </a:solidFill>
-                <a:latin typeface="Calibri" pitchFamily="34" charset="0"/>
-                <a:ea typeface="Calibri" pitchFamily="34" charset="-122"/>
-                <a:cs typeface="Calibri" pitchFamily="34" charset="-120"/>
-              </a:rPr>
-              <a:t>CDR Region Mutations</a:t>
-            </a:r>
-            <a:endParaRPr lang="en-US" sz="1100" dirty="0"/>
-          </a:p>
-        </p:txBody>
-      </p:sp>
-      <p:sp>
-        <p:nvSpPr>
-          <p:cNvPr id="7" name="Shape 3"/>
-          <p:cNvSpPr/>
-          <p:nvPr/>
-        </p:nvSpPr>
-        <p:spPr>
-          <a:xfrm>
-            <a:off x="731520" y="5120640"/>
-            <a:ext cx="10515600" cy="1097280"/>
+      <p:sp>
+        <p:nvSpPr>
+          <p:cNvPr id="5" name="Shape 2"/>
+          <p:cNvSpPr/>
+          <p:nvPr/>
+        </p:nvSpPr>
+        <p:spPr>
+          <a:xfrm>
+            <a:off x="7498080" y="1371600"/>
+            <a:ext cx="4206240" cy="4389120"/>
           </a:xfrm>
           <a:prstGeom prst="roundRect">
             <a:avLst>
-              <a:gd name="adj" fmla="val 8333"/>
+              <a:gd name="adj" fmla="val 3261"/>
             </a:avLst>
           </a:prstGeom>
           <a:solidFill>
@@ -6775,14 +7862,14 @@
       </p:sp>
       <p:sp>
         <p:nvSpPr>
-          <p:cNvPr id="8" name="Text 4"/>
-          <p:cNvSpPr/>
-          <p:nvPr/>
-        </p:nvSpPr>
-        <p:spPr>
-          <a:xfrm>
-            <a:off x="914400" y="5212080"/>
-            <a:ext cx="10149840" cy="914400"/>
+          <p:cNvPr id="6" name="Text 3"/>
+          <p:cNvSpPr/>
+          <p:nvPr/>
+        </p:nvSpPr>
+        <p:spPr>
+          <a:xfrm>
+            <a:off x="7680960" y="1554480"/>
+            <a:ext cx="3840480" cy="365760"/>
           </a:xfrm>
           <a:prstGeom prst="rect">
             <a:avLst/>
@@ -6798,7 +7885,50 @@
               <a:buNone/>
             </a:pPr>
             <a:r>
-              <a:rPr lang="en-US" sz="1300" dirty="0">
+              <a:rPr lang="en-US" sz="1600" b="1" dirty="0">
+                <a:solidFill>
+                  <a:srgbClr val="1A2744"/>
+                </a:solidFill>
+                <a:latin typeface="Calibri" pitchFamily="34" charset="0"/>
+                <a:ea typeface="Calibri" pitchFamily="34" charset="-122"/>
+                <a:cs typeface="Calibri" pitchFamily="34" charset="-120"/>
+              </a:rPr>
+              <a:t>Key Findings</a:t>
+            </a:r>
+            <a:endParaRPr lang="en-US" sz="1600" dirty="0"/>
+          </a:p>
+        </p:txBody>
+      </p:sp>
+      <p:sp>
+        <p:nvSpPr>
+          <p:cNvPr id="7" name="Text 4"/>
+          <p:cNvSpPr/>
+          <p:nvPr/>
+        </p:nvSpPr>
+        <p:spPr>
+          <a:xfrm>
+            <a:off x="7680960" y="2103120"/>
+            <a:ext cx="3840480" cy="640080"/>
+          </a:xfrm>
+          <a:prstGeom prst="rect">
+            <a:avLst/>
+          </a:prstGeom>
+          <a:noFill/>
+          <a:ln/>
+        </p:spPr>
+        <p:txBody>
+          <a:bodyPr wrap="square" lIns="0" tIns="0" rIns="0" bIns="0" rtlCol="0" anchor="ctr"/>
+          <a:lstStyle/>
+          <a:p>
+            <a:pPr marL="342900" indent="-342900">
+              <a:spcAft>
+                <a:spcPts val="400"/>
+              </a:spcAft>
+              <a:buSzPct val="100000"/>
+              <a:buChar char="•"/>
+            </a:pPr>
+            <a:r>
+              <a:rPr lang="en-US" sz="1200" dirty="0">
                 <a:solidFill>
                   <a:srgbClr val="4A5568"/>
                 </a:solidFill>
@@ -6806,9 +7936,138 @@
                 <a:ea typeface="Calibri" pitchFamily="34" charset="-122"/>
                 <a:cs typeface="Calibri" pitchFamily="34" charset="-120"/>
               </a:rPr>
-              <a:t>Mutation counts represent unique nucleotide positions differing from germline. Higher mutation in COVID Naive and Recovered groups suggests mature, affinity-selected B cell responses. CDR mutations indicate antigen-driven selection.</a:t>
-            </a:r>
-            <a:endParaRPr lang="en-US" sz="1300" dirty="0"/>
+              <a:t>Clone count reflects B cell diversity within each subject's repertoire</a:t>
+            </a:r>
+            <a:endParaRPr lang="en-US" sz="1200" dirty="0"/>
+          </a:p>
+        </p:txBody>
+      </p:sp>
+      <p:sp>
+        <p:nvSpPr>
+          <p:cNvPr id="8" name="Text 5"/>
+          <p:cNvSpPr/>
+          <p:nvPr/>
+        </p:nvSpPr>
+        <p:spPr>
+          <a:xfrm>
+            <a:off x="7680960" y="2834640"/>
+            <a:ext cx="3840480" cy="640080"/>
+          </a:xfrm>
+          <a:prstGeom prst="rect">
+            <a:avLst/>
+          </a:prstGeom>
+          <a:noFill/>
+          <a:ln/>
+        </p:spPr>
+        <p:txBody>
+          <a:bodyPr wrap="square" lIns="0" tIns="0" rIns="0" bIns="0" rtlCol="0" anchor="ctr"/>
+          <a:lstStyle/>
+          <a:p>
+            <a:pPr marL="342900" indent="-342900">
+              <a:spcAft>
+                <a:spcPts val="400"/>
+              </a:spcAft>
+              <a:buSzPct val="100000"/>
+              <a:buChar char="•"/>
+            </a:pPr>
+            <a:r>
+              <a:rPr lang="en-US" sz="1200" dirty="0">
+                <a:solidFill>
+                  <a:srgbClr val="4A5568"/>
+                </a:solidFill>
+                <a:latin typeface="Calibri" pitchFamily="34" charset="0"/>
+                <a:ea typeface="Calibri" pitchFamily="34" charset="-122"/>
+                <a:cs typeface="Calibri" pitchFamily="34" charset="-120"/>
+              </a:rPr>
+              <a:t>Severe COVID patients show variable clone counts, reflecting heterogeneous immune responses</a:t>
+            </a:r>
+            <a:endParaRPr lang="en-US" sz="1200" dirty="0"/>
+          </a:p>
+        </p:txBody>
+      </p:sp>
+      <p:sp>
+        <p:nvSpPr>
+          <p:cNvPr id="9" name="Text 6"/>
+          <p:cNvSpPr/>
+          <p:nvPr/>
+        </p:nvSpPr>
+        <p:spPr>
+          <a:xfrm>
+            <a:off x="7680960" y="3566160"/>
+            <a:ext cx="3840480" cy="640080"/>
+          </a:xfrm>
+          <a:prstGeom prst="rect">
+            <a:avLst/>
+          </a:prstGeom>
+          <a:noFill/>
+          <a:ln/>
+        </p:spPr>
+        <p:txBody>
+          <a:bodyPr wrap="square" lIns="0" tIns="0" rIns="0" bIns="0" rtlCol="0" anchor="ctr"/>
+          <a:lstStyle/>
+          <a:p>
+            <a:pPr marL="342900" indent="-342900">
+              <a:spcAft>
+                <a:spcPts val="400"/>
+              </a:spcAft>
+              <a:buSzPct val="100000"/>
+              <a:buChar char="•"/>
+            </a:pPr>
+            <a:r>
+              <a:rPr lang="en-US" sz="1200" dirty="0">
+                <a:solidFill>
+                  <a:srgbClr val="4A5568"/>
+                </a:solidFill>
+                <a:latin typeface="Calibri" pitchFamily="34" charset="0"/>
+                <a:ea typeface="Calibri" pitchFamily="34" charset="-122"/>
+                <a:cs typeface="Calibri" pitchFamily="34" charset="-120"/>
+              </a:rPr>
+              <a:t>Healthy controls (HC1) show consistently lower clone counts</a:t>
+            </a:r>
+            <a:endParaRPr lang="en-US" sz="1200" dirty="0"/>
+          </a:p>
+        </p:txBody>
+      </p:sp>
+      <p:sp>
+        <p:nvSpPr>
+          <p:cNvPr id="10" name="Text 7"/>
+          <p:cNvSpPr/>
+          <p:nvPr/>
+        </p:nvSpPr>
+        <p:spPr>
+          <a:xfrm>
+            <a:off x="7680960" y="4297680"/>
+            <a:ext cx="3840480" cy="640080"/>
+          </a:xfrm>
+          <a:prstGeom prst="rect">
+            <a:avLst/>
+          </a:prstGeom>
+          <a:noFill/>
+          <a:ln/>
+        </p:spPr>
+        <p:txBody>
+          <a:bodyPr wrap="square" lIns="0" tIns="0" rIns="0" bIns="0" rtlCol="0" anchor="ctr"/>
+          <a:lstStyle/>
+          <a:p>
+            <a:pPr marL="342900" indent="-342900">
+              <a:spcAft>
+                <a:spcPts val="400"/>
+              </a:spcAft>
+              <a:buSzPct val="100000"/>
+              <a:buChar char="•"/>
+            </a:pPr>
+            <a:r>
+              <a:rPr lang="en-US" sz="1200" dirty="0">
+                <a:solidFill>
+                  <a:srgbClr val="4A5568"/>
+                </a:solidFill>
+                <a:latin typeface="Calibri" pitchFamily="34" charset="0"/>
+                <a:ea typeface="Calibri" pitchFamily="34" charset="-122"/>
+                <a:cs typeface="Calibri" pitchFamily="34" charset="-120"/>
+              </a:rPr>
+              <a:t>Higher clone counts in Mild/Recovered may indicate broader polyclonal activation</a:t>
+            </a:r>
+            <a:endParaRPr lang="en-US" sz="1200" dirty="0"/>
           </a:p>
         </p:txBody>
       </p:sp>
@@ -6877,7 +8136,7 @@
                 <a:ea typeface="Cambria" pitchFamily="34" charset="-122"/>
                 <a:cs typeface="Cambria" pitchFamily="34" charset="-120"/>
               </a:rPr>
-              <a:t>CDR3 Length Analysis</a:t>
+              <a:t>Expanded Clones Analysis</a:t>
             </a:r>
             <a:endParaRPr lang="en-US" sz="3600" dirty="0"/>
           </a:p>
@@ -6964,7 +8223,7 @@
                 <a:ea typeface="Calibri" pitchFamily="34" charset="-122"/>
                 <a:cs typeface="Calibri" pitchFamily="34" charset="-120"/>
               </a:rPr>
-              <a:t>CDR3 Length (Top 10 Clones, AA)</a:t>
+              <a:t>Count of Expanded Clones (&gt;100 unique seqs)</a:t>
             </a:r>
             <a:endParaRPr lang="en-US" sz="1100" dirty="0"/>
           </a:p>
@@ -7003,7 +8262,7 @@
                 <a:ea typeface="Calibri" pitchFamily="34" charset="-122"/>
                 <a:cs typeface="Calibri" pitchFamily="34" charset="-120"/>
               </a:rPr>
-              <a:t>CDR3 Length Range per Subject</a:t>
+              <a:t>Mean Size of Expanded Clones</a:t>
             </a:r>
             <a:endParaRPr lang="en-US" sz="1100" dirty="0"/>
           </a:p>
@@ -7064,7 +8323,7 @@
                 <a:ea typeface="Calibri" pitchFamily="34" charset="-122"/>
                 <a:cs typeface="Calibri" pitchFamily="34" charset="-120"/>
               </a:rPr>
-              <a:t>CDR3 lengths are relatively consistent across disease categories (~15–16 AA for top clones), suggesting the overall structural constraints on antigen binding are preserved. Greater CDR3 range diversity is observed in COVID Naive and Recovered groups.</a:t>
+              <a:t>Expanded clones (&gt;100 unique sequences) represent antigen-driven clonal expansion. Severe and COVID Naive groups show the highest expansion counts, while expanded clone size reveals the magnitude of individual clonal responses.</a:t>
             </a:r>
             <a:endParaRPr lang="en-US" sz="1300" dirty="0"/>
           </a:p>

</xml_diff>